<commit_message>
feat: fix font handwriting, Kakao yellow, add image-gen + new-company generator
- Fonts: install Pretendard (tools/install_fonts.sh); fixes NanumBrush handwriting
  substitution that broke every deck. Re-rendered all 20 with clean Pretendard.
- Kakao: yellow cover/section (#FEE500) + dark ink, matching the real brand.
- Contrast: accent_ink / on_accent roles so bright accents (yellow/green/orange)
  stay readable on white and on accent fills.
- Images: _engine/place_images.py optional AI hero images (gpt-image-1) with
  graceful placeholder fallback; docs/IMAGES.md OpenAI key setup. Flagship covers
  now ship generated heroes.
- New company: tools/new_company.py one-command scaffold + docs/ADD_A_COMPANY.md.
- README: required font step, image + add-company sections.

Co-Authored-By: Claude Opus 4.8 <noreply@anthropic.com>
</commit_message>
<xml_diff>
--- a/skills/deck-kakao/examples/kakao-6p.pptx
+++ b/skills/deck-kakao/examples/kakao-6p.pptx
@@ -3089,7 +3089,7 @@
     <p:bg>
       <p:bgPr>
         <a:solidFill>
-          <a:srgbClr val="191919"/>
+          <a:srgbClr val="FEE500"/>
         </a:solidFill>
         <a:effectLst/>
       </p:bgPr>
@@ -3181,7 +3181,7 @@
             <a:r>
               <a:rPr sz="1300" b="1" spc="180">
                 <a:solidFill>
-                  <a:srgbClr val="FFFFFF"/>
+                  <a:srgbClr val="191919"/>
                 </a:solidFill>
                 <a:latin typeface="Pretendard"/>
                 <a:ea typeface="Pretendard"/>
@@ -3227,7 +3227,7 @@
             <a:r>
               <a:rPr sz="5400" b="1">
                 <a:solidFill>
-                  <a:srgbClr val="FFFFFF"/>
+                  <a:srgbClr val="191919"/>
                 </a:solidFill>
                 <a:latin typeface="Pretendard"/>
                 <a:ea typeface="Pretendard"/>
@@ -3251,7 +3251,7 @@
             <a:r>
               <a:rPr sz="1600" b="0">
                 <a:solidFill>
-                  <a:srgbClr val="FFFFFF"/>
+                  <a:srgbClr val="191919"/>
                 </a:solidFill>
                 <a:latin typeface="Pretendard"/>
                 <a:ea typeface="Pretendard"/>
@@ -3501,7 +3501,7 @@
             <a:r>
               <a:rPr sz="1700" b="1">
                 <a:solidFill>
-                  <a:srgbClr val="191919"/>
+                  <a:srgbClr val="3B1E1E"/>
                 </a:solidFill>
                 <a:latin typeface="Pretendard"/>
                 <a:ea typeface="Pretendard"/>
@@ -3683,7 +3683,7 @@
             <a:r>
               <a:rPr sz="1700" b="1">
                 <a:solidFill>
-                  <a:srgbClr val="191919"/>
+                  <a:srgbClr val="3B1E1E"/>
                 </a:solidFill>
                 <a:latin typeface="Pretendard"/>
                 <a:ea typeface="Pretendard"/>
@@ -3865,7 +3865,7 @@
             <a:r>
               <a:rPr sz="1700" b="1">
                 <a:solidFill>
-                  <a:srgbClr val="191919"/>
+                  <a:srgbClr val="3B1E1E"/>
                 </a:solidFill>
                 <a:latin typeface="Pretendard"/>
                 <a:ea typeface="Pretendard"/>
@@ -4047,7 +4047,7 @@
             <a:r>
               <a:rPr sz="1700" b="1">
                 <a:solidFill>
-                  <a:srgbClr val="191919"/>
+                  <a:srgbClr val="3B1E1E"/>
                 </a:solidFill>
                 <a:latin typeface="Pretendard"/>
                 <a:ea typeface="Pretendard"/>
@@ -4163,7 +4163,7 @@
     <p:bg>
       <p:bgPr>
         <a:solidFill>
-          <a:srgbClr val="191919"/>
+          <a:srgbClr val="FEE500"/>
         </a:solidFill>
         <a:effectLst/>
       </p:bgPr>
@@ -4190,7 +4190,7 @@
             <a:avLst/>
           </a:prstGeom>
           <a:solidFill>
-            <a:srgbClr val="FEE500"/>
+            <a:srgbClr val="191919"/>
           </a:solidFill>
           <a:ln>
             <a:noFill/>
@@ -4255,7 +4255,7 @@
             <a:r>
               <a:rPr sz="5600" b="1">
                 <a:solidFill>
-                  <a:srgbClr val="FFFFFF"/>
+                  <a:srgbClr val="191919"/>
                 </a:solidFill>
                 <a:latin typeface="Pretendard"/>
                 <a:ea typeface="Pretendard"/>
@@ -4278,7 +4278,7 @@
             <a:r>
               <a:rPr sz="3800" b="1">
                 <a:solidFill>
-                  <a:srgbClr val="FFFFFF"/>
+                  <a:srgbClr val="191919"/>
                 </a:solidFill>
                 <a:latin typeface="Pretendard"/>
                 <a:ea typeface="Pretendard"/>
@@ -4301,7 +4301,7 @@
             <a:r>
               <a:rPr sz="1500" b="0">
                 <a:solidFill>
-                  <a:srgbClr val="FFFFFF"/>
+                  <a:srgbClr val="191919"/>
                 </a:solidFill>
                 <a:latin typeface="Pretendard"/>
                 <a:ea typeface="Pretendard"/>
@@ -4373,7 +4373,7 @@
             <a:r>
               <a:rPr sz="1100" b="1" spc="120">
                 <a:solidFill>
-                  <a:srgbClr val="191919"/>
+                  <a:srgbClr val="3B1E1E"/>
                 </a:solidFill>
                 <a:latin typeface="Pretendard"/>
                 <a:ea typeface="Pretendard"/>
@@ -5353,7 +5353,7 @@
             <a:r>
               <a:rPr sz="1100" b="1" spc="120">
                 <a:solidFill>
-                  <a:srgbClr val="191919"/>
+                  <a:srgbClr val="3B1E1E"/>
                 </a:solidFill>
                 <a:latin typeface="Pretendard"/>
                 <a:ea typeface="Pretendard"/>
@@ -5627,7 +5627,7 @@
     <p:bg>
       <p:bgPr>
         <a:solidFill>
-          <a:srgbClr val="191919"/>
+          <a:srgbClr val="FEE500"/>
         </a:solidFill>
         <a:effectLst/>
       </p:bgPr>
@@ -5719,7 +5719,7 @@
             <a:r>
               <a:rPr sz="4000" b="1">
                 <a:solidFill>
-                  <a:srgbClr val="FFFFFF"/>
+                  <a:srgbClr val="191919"/>
                 </a:solidFill>
                 <a:latin typeface="Pretendard"/>
                 <a:ea typeface="Pretendard"/>
@@ -5743,7 +5743,7 @@
             <a:r>
               <a:rPr sz="1500" b="0">
                 <a:solidFill>
-                  <a:srgbClr val="FFFFFF"/>
+                  <a:srgbClr val="191919"/>
                 </a:solidFill>
                 <a:latin typeface="Pretendard"/>
                 <a:ea typeface="Pretendard"/>
@@ -5789,7 +5789,7 @@
             <a:r>
               <a:rPr sz="1100" b="0">
                 <a:solidFill>
-                  <a:srgbClr val="FFFFFF"/>
+                  <a:srgbClr val="191919"/>
                 </a:solidFill>
                 <a:latin typeface="Pretendard"/>
                 <a:ea typeface="Pretendard"/>

</xml_diff>